<commit_message>
Deck: four-model reasoning figure, OLMo clarification null, stock-phrase finding in next steps
Co-Authored-By: Claude Opus 5.5 <noreply@anthropic.com>
</commit_message>
<xml_diff>
--- a/briefings/phase3-findings-12min.pptx
+++ b/briefings/phase3-findings-12min.pptx
@@ -380,7 +380,7 @@
           <a:lstStyle/>
           <a:p>
             <a:r>
-              <a:t>Three follow-ups for the fall. First, pay the model while it reasons. Payment through training could not teach arithmetic to snap answers, but the model already does the arithmetic when it thinks first, so that is where payment can test what instructions cannot: whether you can install a specific risk-averse utility, and whether paid reasoning carries over to snap answers. Second, finish the staircase. With reasoning, the later training stages remove most of the loss-wording effect, and one more checkpoint tells us which stage does it. Third, the same machinery measures social preferences, so we ask whether a model cooperates more with a counterpart it takes for its own kind. Most of the money personality arrives at one training step, and that is where to start looking. Thank you.</a:t>
+              <a:t>Three follow-ups for the fall. First, pay the model while it reasons. Payment through training could not teach arithmetic to snap answers, but the model already does the arithmetic when it thinks first, so that is where payment can test what instructions cannot: whether you can install a specific risk-averse utility, and whether paid reasoning carries over to snap answers. Second, read the reasoning closely. When Qwen got a question wrong outside the loss wording, it usually did the arithmetic right and then wrote the verdict backward, and nearly every one came after the same phrase: which is less than the guaranteed amount. Given the correct number, the model says less after that phrase almost regardless of the numbers. Anyone auditing an AI by its reasoning should know that a trace can show the right calculation and a verdict supplied by habit. We want to know whether other families have their own habits. Third, the same machinery measures social preferences, so we ask whether a model cooperates more with a counterpart it takes for its own kind. Most of the money personality arrives at one training step, and that is where to start looking. Thank you.</a:t>
             </a:r>
           </a:p>
         </p:txBody>
@@ -454,7 +454,7 @@
           <a:lstStyle/>
           <a:p>
             <a:r>
-              <a:t>So we tested that directly. We let the models write out their reasoning before giving the letter, and asked the same questions. On the left, told to maximize expected value: answering at once, compliance sits in the fifties, a coin flip. Reasoning first, the finished Qwen assistant follows the rule ninety-six percent of the time, and OLMo eighty. The ceiling was the format, not the model. On the right is the wording effect with no instruction at all. Answering at once, Qwen gambles sixty-three points more when a bet is called a loss. Reasoning first, it gambles fourteen points less, the direction Claude Haiku took in our earlier phase. So the same model reverses its reaction to loss wording depending on whether it thinks first. The written reasoning tells us why.</a:t>
+              <a:t>So we tested that directly. We let the models write out their reasoning before giving the letter, and asked the same questions. On the left, told to maximize expected value: answering at once, compliance sits in the fifties, a coin flip. Reasoning first, the finished Qwen assistant follows the rule ninety-six percent of the time, and OLMo eighty. The ceiling was the format, not the model. On the right is the wording effect with no instruction at all. Answering at once, Qwen gambles sixty-three points more when a bet is called a loss. Reasoning first, it gambles fourteen points less, the direction Claude Haiku took in our earlier phase. So the same model reverses its reaction to loss wording depending on whether it thinks first. In OLMo, the checkpoint after fine-tuning still gambles thirty-seven points more under loss wording when it reasons; one stage later, right after preference training, the gap is gone, and the final stage changes nothing. Preference training leaves the snap-answer preferences alone and changes how the model reasons. The written reasoning tells us why the wording effect flips.</a:t>
             </a:r>
           </a:p>
         </p:txBody>
@@ -500,7 +500,7 @@
           <a:lstStyle/>
           <a:p>
             <a:r>
-              <a:t>Here is what the reasoning showed. Given a loss-worded bet, Qwen treats the gamble as a change in its money, say an average gain of eight dollars, and the sure option as a total, ninety-eight dollars, and of course the total wins. Every one of its twenty-one errors went toward the safe choice. So we added one sentence: compare the final dollar amounts. The errors fell from twenty-one to zero, and the wording effect disappeared. We also tried the economist's other lever, payment. We paid the model through training for its snap answers, and in all six versions it learned to give one fixed answer, never the arithmetic. None of the leftover mistakes mentions risk. This is a habit of arithmetic, not a preference. Let me pull it together.</a:t>
+              <a:t>Here is what the reasoning showed. Given a loss-worded bet, Qwen treats the gamble as a change in its money, say an average gain of eight dollars, and the sure option as a total, ninety-eight dollars, and of course the total wins. Every one of its twenty-one errors went toward the safe choice. So we added one sentence: compare the final dollar amounts. The errors fell from twenty-one to zero, and the wording effect disappeared. OLMo makes the same mistake, and the same sentence does nothing for it: it goes on multiplying the gain instead of the total. We also tried the economist's other lever, payment. We paid the model through training for its snap answers, and in all six versions it learned to give one fixed answer, never the arithmetic. None of the leftover mistakes mentions risk. This is a habit of arithmetic, not a preference. Let me pull it together.</a:t>
             </a:r>
           </a:p>
         </p:txBody>
@@ -3372,7 +3372,7 @@
                 <a:ea typeface="Helvetica Neue" pitchFamily="34" charset="-122"/>
                 <a:cs typeface="Helvetica Neue" pitchFamily="34" charset="-120"/>
               </a:rPr>
-              <a:t>Add “compare the final dollar amounts” to the instruction and the errors fall from 21 to zero. The gap between gain and loss wording goes to exactly zero.</a:t>
+              <a:t>Add “compare the final dollar amounts” and Qwen’s errors fall from 21 to zero. OLMo makes the same mistake and ignores the sentence.</a:t>
             </a:r>
             <a:endParaRPr lang="en-US" sz="1600" dirty="0"/>
           </a:p>
@@ -5764,7 +5764,7 @@
                 <a:ea typeface="Georgia" pitchFamily="34" charset="-122"/>
                 <a:cs typeface="Georgia" pitchFamily="34" charset="-120"/>
               </a:rPr>
-              <a:t>Finish the staircase</a:t>
+              <a:t>Read the reasoning closely</a:t>
             </a:r>
             <a:endParaRPr lang="en-US" sz="2700" dirty="0"/>
           </a:p>
@@ -5806,7 +5806,7 @@
                 <a:ea typeface="Helvetica Neue" pitchFamily="34" charset="-122"/>
                 <a:cs typeface="Helvetica Neue" pitchFamily="34" charset="-120"/>
               </a:rPr>
-              <a:t>Run the checkpoint after preference training with reasoning, to see which of the two later training stages removes the loss-wording effect.</a:t>
+              <a:t>Qwen’s wrong verdicts came from one stock phrase, “which is less than”. Test whether OLMo and Llama have habits of their own.</a:t>
             </a:r>
             <a:endParaRPr lang="en-US" sz="1700" dirty="0"/>
           </a:p>
@@ -13536,22 +13536,22 @@
       </p:sp>
       <p:pic>
         <p:nvPicPr>
-          <p:cNvPr id="26" name="Image 1" descr="reason.png"/>
+          <p:cNvPr id="27" name="Image 1" descr="tr_crop.png"/>
           <p:cNvPicPr>
             <a:picLocks noChangeAspect="1"/>
           </p:cNvPicPr>
           <p:nvPr/>
         </p:nvPicPr>
         <p:blipFill>
-          <a:blip r:embed="rId2"/>
+          <a:blip r:embed="rId6"/>
           <a:stretch>
             <a:fillRect/>
           </a:stretch>
         </p:blipFill>
         <p:spPr>
           <a:xfrm>
-            <a:off x="3332091" y="2377440"/>
-            <a:ext cx="8880617" cy="5349240"/>
+            <a:off x="3600772" y="2377440"/>
+            <a:ext cx="8343254" cy="5349240"/>
           </a:xfrm>
           <a:prstGeom prst="rect">
             <a:avLst/>

</xml_diff>

<commit_message>
Decks: Llama in the 12-minute deck; new 5-minute project overview
- phase3-findings-12min: five-model reasoning figure (Llama added), Llama verdict habit in
  slide 12 and notes.
- project-overview-5min: seven slides built from the 12-minute deck by
  briefings/build_overview_5min.py (Phases 1-3, reasoning arm, trace habits, takeaways).

Co-Authored-By: Claude Opus 5.5 <noreply@anthropic.com>
</commit_message>
<xml_diff>
--- a/briefings/phase3-findings-12min.pptx
+++ b/briefings/phase3-findings-12min.pptx
@@ -380,7 +380,7 @@
           <a:lstStyle/>
           <a:p>
             <a:r>
-              <a:t>Three follow-ups for the fall. First, pay the model while it reasons. Payment through training could not teach arithmetic to snap answers, but the model already does the arithmetic when it thinks first, so that is where payment can test what instructions cannot: whether you can install a specific risk-averse utility, and whether paid reasoning carries over to snap answers. Second, read the reasoning closely. When Qwen got a question wrong outside the loss wording, it usually did the arithmetic right and then wrote the verdict backward, and nearly every one came after the same phrase: which is less than the guaranteed amount. Given the correct number, the model says less after that phrase almost regardless of the numbers. Anyone auditing an AI by its reasoning should know that a trace can show the right calculation and a verdict supplied by habit. We want to know whether other families have their own habits. Third, the same machinery measures social preferences, so we ask whether a model cooperates more with a counterpart it takes for its own kind. Most of the money personality arrives at one training step, and that is where to start looking. Thank you.</a:t>
+              <a:t>Three follow-ups for the fall. First, pay the model while it reasons. Payment through training could not teach arithmetic to snap answers, but the model already does the arithmetic when it thinks first, so that is where payment can test what instructions cannot: whether you can install a specific risk-averse utility, and whether paid reasoning carries over to snap answers. Second, read the reasoning closely. When Qwen got a question wrong outside the loss wording, it usually did the arithmetic right and then wrote the verdict backward, and nearly every one came after the same phrase: which is less than the guaranteed amount. Given the correct number, the model says less after that phrase almost regardless of the numbers. Anyone auditing an AI by its reasoning should know that a trace can show the right calculation and a verdict supplied by habit. Llama has a habit too, pointed the other way: it writes since the gamble is greater than the sure amount when it is not, mostly when the gamble is listed first. So every family needs its own check, and we want to know whether rewording the instruction can remove a habit. Third, the same machinery measures social preferences, so we ask whether a model cooperates more with a counterpart it takes for its own kind. Most of the money personality arrives at one training step, and that is where to start looking. Thank you.</a:t>
             </a:r>
           </a:p>
         </p:txBody>
@@ -454,7 +454,7 @@
           <a:lstStyle/>
           <a:p>
             <a:r>
-              <a:t>So we tested that directly. We let the models write out their reasoning before giving the letter, and asked the same questions. On the left, told to maximize expected value: answering at once, compliance sits in the fifties, a coin flip. Reasoning first, the finished Qwen assistant follows the rule ninety-six percent of the time, and OLMo eighty. The ceiling was the format, not the model. On the right is the wording effect with no instruction at all. Answering at once, Qwen gambles sixty-three points more when a bet is called a loss. Reasoning first, it gambles fourteen points less, the direction Claude Haiku took in our earlier phase. So the same model reverses its reaction to loss wording depending on whether it thinks first. In OLMo, the checkpoint after fine-tuning still gambles thirty-seven points more under loss wording when it reasons; one stage later, right after preference training, the gap is gone, and the final stage changes nothing. Preference training leaves the snap-answer preferences alone and changes how the model reasons. The written reasoning tells us why the wording effect flips.</a:t>
+              <a:t>So we tested that directly. We let the models write out their reasoning before giving the letter, and asked the same questions. On the left, told to maximize expected value: answering at once, compliance sits in the fifties, a coin flip. Reasoning first, the finished Qwen assistant follows the rule ninety-six percent of the time, and OLMo eighty. The ceiling was the format, not the model. On the right is the wording effect with no instruction at all. Answering at once, Qwen gambles sixty-three points more when a bet is called a loss. Reasoning first, it gambles fourteen points less, the direction Claude Haiku took in our earlier phase. So the same model reverses its reaction to loss wording depending on whether it thinks first. In OLMo, the checkpoint after fine-tuning still gambles thirty-seven points more under loss wording when it reasons; one stage later, right after preference training, the gap is gone, and the final stage changes nothing. Preference training leaves the snap-answer preferences alone and changes how the model reasons. Llama, the third family, follows the same pattern: fifty-two percent answering at once with no rule, ninety-five percent reasoning first with the rule (we never ran it at once with the rule), and it barely reacts to loss wording either way. The written reasoning tells us why the wording effect flips.</a:t>
             </a:r>
           </a:p>
         </p:txBody>
@@ -5806,7 +5806,7 @@
                 <a:ea typeface="Helvetica Neue" pitchFamily="34" charset="-122"/>
                 <a:cs typeface="Helvetica Neue" pitchFamily="34" charset="-120"/>
               </a:rPr>
-              <a:t>Qwen’s wrong verdicts came from one stock phrase, “which is less than”. Test whether OLMo and Llama have habits of their own.</a:t>
+              <a:t>Qwen’s wrong verdicts lean safe, through one stock phrase; Llama’s lean toward whichever option it read first. Can rewording the instruction remove a habit?</a:t>
             </a:r>
             <a:endParaRPr lang="en-US" sz="1700" dirty="0"/>
           </a:p>
@@ -13536,22 +13536,22 @@
       </p:sp>
       <p:pic>
         <p:nvPicPr>
-          <p:cNvPr id="27" name="Image 1" descr="tr_crop.png"/>
+          <p:cNvPr id="28" name="Image 1" descr="tr_crop.png"/>
           <p:cNvPicPr>
             <a:picLocks noChangeAspect="1"/>
           </p:cNvPicPr>
           <p:nvPr/>
         </p:nvPicPr>
         <p:blipFill>
-          <a:blip r:embed="rId6"/>
+          <a:blip r:embed="rId7"/>
           <a:stretch>
             <a:fillRect/>
           </a:stretch>
         </p:blipFill>
         <p:spPr>
           <a:xfrm>
-            <a:off x="3600772" y="2377440"/>
-            <a:ext cx="8343254" cy="5349240"/>
+            <a:off x="3318800" y="2377440"/>
+            <a:ext cx="8907198" cy="5349240"/>
           </a:xfrm>
           <a:prstGeom prst="rect">
             <a:avLst/>

</xml_diff>

<commit_message>
Extension: do the measured risk habits carry into advice? Design note, decks and papers
docs/extension-advice-2026-10.md: Stage A maps the Phase 3 gambles number for number into
national-security advisory questions (domains x roles x frames x orders); Stage B uses
open-ended scenario briefs coded for risk posture. Added as the fourth next step in both
decks; fixed duplicate shape ids in the 12-minute deck.

Co-Authored-By: Claude Opus 5.5 <noreply@anthropic.com>
</commit_message>
<xml_diff>
--- a/briefings/phase3-findings-12min.pptx
+++ b/briefings/phase3-findings-12min.pptx
@@ -380,7 +380,7 @@
           <a:lstStyle/>
           <a:p>
             <a:r>
-              <a:t>Three follow-ups for the fall. First, pay the model while it reasons. Payment through training could not teach arithmetic to snap answers, but the model already does the arithmetic when it thinks first, so that is where payment can test what instructions cannot: whether you can install a specific risk-averse utility, and whether paid reasoning carries over to snap answers. Second, read the reasoning closely. When Qwen got a question wrong outside the loss wording, it usually did the arithmetic right and then wrote the verdict backward, and nearly every one came after the same phrase: which is less than the guaranteed amount. Given the correct number, the model says less after that phrase almost regardless of the numbers. Anyone auditing an AI by its reasoning should know that a trace can show the right calculation and a verdict supplied by habit. Llama has a habit too, pointed the other way: it writes since the gamble is greater than the sure amount when it is not, mostly when the gamble is listed first. So every family needs its own check, and we want to know whether rewording the instruction can remove a habit. Third, the same machinery measures social preferences, so we ask whether a model cooperates more with a counterpart it takes for its own kind. Most of the money personality arrives at one training step, and that is where to start looking. Thank you.</a:t>
+              <a:t>Three follow-ups for the fall. First, pay the model while it reasons. Payment through training could not teach arithmetic to snap answers, but the model already does the arithmetic when it thinks first, so that is where payment can test what instructions cannot: whether you can install a specific risk-averse utility, and whether paid reasoning carries over to snap answers. Second, read the reasoning closely. When Qwen got a question wrong outside the loss wording, it usually did the arithmetic right and then wrote the verdict backward, and nearly every one came after the same phrase: which is less than the guaranteed amount. Given the correct number, the model says less after that phrase almost regardless of the numbers. Anyone auditing an AI by its reasoning should know that a trace can show the right calculation and a verdict supplied by habit. Llama has a habit too, pointed the other way: it writes since the gamble is greater than the sure amount when it is not, mostly when the gamble is listed first. So every family needs its own check, and we want to know whether rewording the instruction can remove a habit. Third, the same machinery measures social preferences, so we ask whether a model cooperates more with a counterpart it takes for its own kind. Fourth, once we know a model's risk habits, we ask whether they show up in the advice it gives. A commander or an official asks it to choose between a cautious and a risky course of action, with the same numbers as our bets but in lives or territory. If the bets predict the advice, sixteen hundred questions become a cheap screening test for advisory use; if not, the audit has to be run on the advice itself. Most of the money personality arrives at one training step, and that is where to start looking. Thank you.</a:t>
             </a:r>
           </a:p>
         </p:txBody>
@@ -2093,7 +2093,7 @@
       </p:sp>
       <p:sp>
         <p:nvSpPr>
-          <p:cNvPr id="18" name="Shape 15"/>
+          <p:cNvPr id="27" name="Shape 15"/>
           <p:cNvSpPr/>
           <p:nvPr/>
         </p:nvSpPr>
@@ -2151,7 +2151,7 @@
       </p:sp>
       <p:sp>
         <p:nvSpPr>
-          <p:cNvPr id="18" name="Shape 15"/>
+          <p:cNvPr id="28" name="Shape 15"/>
           <p:cNvSpPr/>
           <p:nvPr/>
         </p:nvSpPr>
@@ -2835,7 +2835,7 @@
       </p:sp>
       <p:sp>
         <p:nvSpPr>
-          <p:cNvPr id="14" name="Shape 11"/>
+          <p:cNvPr id="36" name="Shape 11"/>
           <p:cNvSpPr/>
           <p:nvPr/>
         </p:nvSpPr>
@@ -2864,7 +2864,7 @@
       </p:sp>
       <p:sp>
         <p:nvSpPr>
-          <p:cNvPr id="14" name="Shape 11"/>
+          <p:cNvPr id="37" name="Shape 11"/>
           <p:cNvSpPr/>
           <p:nvPr/>
         </p:nvSpPr>
@@ -4031,7 +4031,7 @@
       </p:sp>
       <p:sp>
         <p:nvSpPr>
-          <p:cNvPr id="14" name="Shape 11"/>
+          <p:cNvPr id="36" name="Shape 11"/>
           <p:cNvSpPr/>
           <p:nvPr/>
         </p:nvSpPr>
@@ -4060,7 +4060,7 @@
       </p:sp>
       <p:sp>
         <p:nvSpPr>
-          <p:cNvPr id="14" name="Shape 11"/>
+          <p:cNvPr id="37" name="Shape 11"/>
           <p:cNvSpPr/>
           <p:nvPr/>
         </p:nvSpPr>
@@ -4956,7 +4956,7 @@
                 <a:ea typeface="Helvetica Neue" pitchFamily="34" charset="-122"/>
                 <a:cs typeface="Helvetica Neue" pitchFamily="34" charset="-120"/>
               </a:rPr>
-              <a:t>Three projects for the fall, in order of how much they would change the answer.</a:t>
+              <a:t>Four projects for the fall.</a:t>
             </a:r>
             <a:endParaRPr lang="en-US" sz="2000" dirty="0"/>
           </a:p>
@@ -5269,7 +5269,7 @@
       </p:sp>
       <p:sp>
         <p:nvSpPr>
-          <p:cNvPr id="14" name="Shape 11"/>
+          <p:cNvPr id="36" name="Shape 11"/>
           <p:cNvSpPr/>
           <p:nvPr/>
         </p:nvSpPr>
@@ -5298,7 +5298,7 @@
       </p:sp>
       <p:sp>
         <p:nvSpPr>
-          <p:cNvPr id="14" name="Shape 11"/>
+          <p:cNvPr id="37" name="Shape 11"/>
           <p:cNvSpPr/>
           <p:nvPr/>
         </p:nvSpPr>
@@ -5592,8 +5592,8 @@
         </p:nvSpPr>
         <p:spPr>
           <a:xfrm>
-            <a:off x="457200" y="3794760"/>
-            <a:ext cx="4480560" cy="0"/>
+            <a:off x="457200" y="2743200"/>
+            <a:ext cx="3291840" cy="0"/>
           </a:xfrm>
           <a:prstGeom prst="line">
             <a:avLst/>
@@ -5622,8 +5622,8 @@
         </p:nvSpPr>
         <p:spPr>
           <a:xfrm>
-            <a:off x="457200" y="3977640"/>
-            <a:ext cx="4480560" cy="1097280"/>
+            <a:off x="457200" y="2926080"/>
+            <a:ext cx="3291840" cy="1097280"/>
           </a:xfrm>
           <a:prstGeom prst="rect">
             <a:avLst/>
@@ -5664,8 +5664,8 @@
         </p:nvSpPr>
         <p:spPr>
           <a:xfrm>
-            <a:off x="457200" y="4800600"/>
-            <a:ext cx="4480560" cy="2651760"/>
+            <a:off x="457200" y="4160520"/>
+            <a:ext cx="3291840" cy="2651760"/>
           </a:xfrm>
           <a:prstGeom prst="rect">
             <a:avLst/>
@@ -5706,8 +5706,8 @@
         </p:nvSpPr>
         <p:spPr>
           <a:xfrm>
-            <a:off x="5532120" y="3794760"/>
-            <a:ext cx="4480560" cy="0"/>
+            <a:off x="4236415" y="2743200"/>
+            <a:ext cx="3291840" cy="0"/>
           </a:xfrm>
           <a:prstGeom prst="line">
             <a:avLst/>
@@ -5736,8 +5736,8 @@
         </p:nvSpPr>
         <p:spPr>
           <a:xfrm>
-            <a:off x="5532120" y="3977640"/>
-            <a:ext cx="4480560" cy="1097280"/>
+            <a:off x="4236415" y="2926080"/>
+            <a:ext cx="3291840" cy="1097280"/>
           </a:xfrm>
           <a:prstGeom prst="rect">
             <a:avLst/>
@@ -5778,8 +5778,8 @@
         </p:nvSpPr>
         <p:spPr>
           <a:xfrm>
-            <a:off x="5532120" y="4800600"/>
-            <a:ext cx="4480560" cy="2651760"/>
+            <a:off x="4236415" y="4160520"/>
+            <a:ext cx="3291840" cy="2651760"/>
           </a:xfrm>
           <a:prstGeom prst="rect">
             <a:avLst/>
@@ -5820,8 +5820,8 @@
         </p:nvSpPr>
         <p:spPr>
           <a:xfrm>
-            <a:off x="10607040" y="3794760"/>
-            <a:ext cx="4480560" cy="0"/>
+            <a:off x="8015630" y="2743200"/>
+            <a:ext cx="3291840" cy="0"/>
           </a:xfrm>
           <a:prstGeom prst="line">
             <a:avLst/>
@@ -5850,8 +5850,8 @@
         </p:nvSpPr>
         <p:spPr>
           <a:xfrm>
-            <a:off x="10607040" y="3977640"/>
-            <a:ext cx="4480560" cy="1097280"/>
+            <a:off x="8015630" y="2926080"/>
+            <a:ext cx="3291840" cy="1097280"/>
           </a:xfrm>
           <a:prstGeom prst="rect">
             <a:avLst/>
@@ -5892,8 +5892,8 @@
         </p:nvSpPr>
         <p:spPr>
           <a:xfrm>
-            <a:off x="10607040" y="4800600"/>
-            <a:ext cx="4480560" cy="2651760"/>
+            <a:off x="8015630" y="4160520"/>
+            <a:ext cx="3291840" cy="2651760"/>
           </a:xfrm>
           <a:prstGeom prst="rect">
             <a:avLst/>
@@ -5921,6 +5921,120 @@
                 <a:cs typeface="Helvetica Neue" pitchFamily="34" charset="-120"/>
               </a:rPr>
               <a:t>The same machinery measures social preferences. Does a model cooperate more with a counterpart it believes comes from its own family? Multi-agent deployments make that a procurement question.</a:t>
+            </a:r>
+            <a:endParaRPr lang="en-US" sz="1700" dirty="0"/>
+          </a:p>
+        </p:txBody>
+      </p:sp>
+      <p:sp>
+        <p:nvSpPr>
+          <p:cNvPr id="33" name="Shape 30"/>
+          <p:cNvSpPr/>
+          <p:nvPr/>
+        </p:nvSpPr>
+        <p:spPr>
+          <a:xfrm>
+            <a:off x="11794845" y="2743200"/>
+            <a:ext cx="3291840" cy="0"/>
+          </a:xfrm>
+          <a:prstGeom prst="line">
+            <a:avLst/>
+          </a:prstGeom>
+          <a:noFill/>
+          <a:ln w="12700">
+            <a:solidFill>
+              <a:srgbClr val="761DDB"/>
+            </a:solidFill>
+            <a:prstDash val="solid"/>
+          </a:ln>
+        </p:spPr>
+        <p:txBody>
+          <a:bodyPr/>
+          <a:lstStyle/>
+          <a:p>
+            <a:endParaRPr lang="en-US"/>
+          </a:p>
+        </p:txBody>
+      </p:sp>
+      <p:sp>
+        <p:nvSpPr>
+          <p:cNvPr id="34" name="Text 31"/>
+          <p:cNvSpPr txBox="1"/>
+          <p:nvPr/>
+        </p:nvSpPr>
+        <p:spPr>
+          <a:xfrm>
+            <a:off x="11794845" y="2926080"/>
+            <a:ext cx="3291840" cy="1097280"/>
+          </a:xfrm>
+          <a:prstGeom prst="rect">
+            <a:avLst/>
+          </a:prstGeom>
+          <a:noFill/>
+          <a:ln/>
+        </p:spPr>
+        <p:txBody>
+          <a:bodyPr wrap="square" lIns="0" tIns="0" rIns="0" bIns="0" rtlCol="0" anchor="t"/>
+          <a:lstStyle/>
+          <a:p>
+            <a:pPr marL="0" indent="0">
+              <a:lnSpc>
+                <a:spcPct val="115000"/>
+              </a:lnSpc>
+              <a:buNone/>
+            </a:pPr>
+            <a:r>
+              <a:rPr lang="en-US" sz="2700" dirty="0">
+                <a:solidFill>
+                  <a:srgbClr val="1C1C1E"/>
+                </a:solidFill>
+                <a:latin typeface="Georgia" pitchFamily="34" charset="0"/>
+                <a:ea typeface="Georgia" pitchFamily="34" charset="-122"/>
+                <a:cs typeface="Georgia" pitchFamily="34" charset="-120"/>
+              </a:rPr>
+              <a:t>Does it carry into advice?</a:t>
+            </a:r>
+            <a:endParaRPr lang="en-US" sz="2700" dirty="0"/>
+          </a:p>
+        </p:txBody>
+      </p:sp>
+      <p:sp>
+        <p:nvSpPr>
+          <p:cNvPr id="35" name="Text 32"/>
+          <p:cNvSpPr txBox="1"/>
+          <p:nvPr/>
+        </p:nvSpPr>
+        <p:spPr>
+          <a:xfrm>
+            <a:off x="11794845" y="4160520"/>
+            <a:ext cx="3291840" cy="2651760"/>
+          </a:xfrm>
+          <a:prstGeom prst="rect">
+            <a:avLst/>
+          </a:prstGeom>
+          <a:noFill/>
+          <a:ln/>
+        </p:spPr>
+        <p:txBody>
+          <a:bodyPr wrap="square" lIns="0" tIns="0" rIns="0" bIns="0" rtlCol="0" anchor="t"/>
+          <a:lstStyle/>
+          <a:p>
+            <a:pPr marL="0" indent="0">
+              <a:lnSpc>
+                <a:spcPct val="140000"/>
+              </a:lnSpc>
+              <a:buNone/>
+            </a:pPr>
+            <a:r>
+              <a:rPr lang="en-US" sz="1700" dirty="0">
+                <a:solidFill>
+                  <a:srgbClr val="1C1C1E"/>
+                </a:solidFill>
+                <a:latin typeface="Helvetica Neue" pitchFamily="34" charset="0"/>
+                <a:ea typeface="Helvetica Neue" pitchFamily="34" charset="-122"/>
+                <a:cs typeface="Helvetica Neue" pitchFamily="34" charset="-120"/>
+              </a:rPr>
+              <a:t>Ask the same bets as advice to a commander or an official, in lives and territory instead of dollars. Do the risk and wording habits predict the recommendation?</a:t>
             </a:r>
             <a:endParaRPr lang="en-US" sz="1700" dirty="0"/>
           </a:p>
@@ -6393,7 +6507,7 @@
       </p:sp>
       <p:sp>
         <p:nvSpPr>
-          <p:cNvPr id="14" name="Shape 11"/>
+          <p:cNvPr id="33" name="Shape 11"/>
           <p:cNvSpPr/>
           <p:nvPr/>
         </p:nvSpPr>
@@ -6420,7 +6534,7 @@
       </p:sp>
       <p:sp>
         <p:nvSpPr>
-          <p:cNvPr id="14" name="Shape 11"/>
+          <p:cNvPr id="34" name="Shape 11"/>
           <p:cNvSpPr/>
           <p:nvPr/>
         </p:nvSpPr>
@@ -7517,7 +7631,7 @@
       </p:sp>
       <p:sp>
         <p:nvSpPr>
-          <p:cNvPr id="14" name="Shape 11"/>
+          <p:cNvPr id="41" name="Shape 11"/>
           <p:cNvSpPr/>
           <p:nvPr/>
         </p:nvSpPr>
@@ -7546,7 +7660,7 @@
       </p:sp>
       <p:sp>
         <p:nvSpPr>
-          <p:cNvPr id="14" name="Shape 11"/>
+          <p:cNvPr id="42" name="Shape 11"/>
           <p:cNvSpPr/>
           <p:nvPr/>
         </p:nvSpPr>
@@ -8937,7 +9051,7 @@
       </p:sp>
       <p:sp>
         <p:nvSpPr>
-          <p:cNvPr id="14" name="Shape 11"/>
+          <p:cNvPr id="26" name="Shape 11"/>
           <p:cNvSpPr/>
           <p:nvPr/>
         </p:nvSpPr>
@@ -8966,7 +9080,7 @@
       </p:sp>
       <p:sp>
         <p:nvSpPr>
-          <p:cNvPr id="14" name="Shape 11"/>
+          <p:cNvPr id="27" name="Shape 11"/>
           <p:cNvSpPr/>
           <p:nvPr/>
         </p:nvSpPr>
@@ -9785,7 +9899,7 @@
       </p:sp>
       <p:sp>
         <p:nvSpPr>
-          <p:cNvPr id="14" name="Shape 11"/>
+          <p:cNvPr id="26" name="Shape 11"/>
           <p:cNvSpPr/>
           <p:nvPr/>
         </p:nvSpPr>
@@ -9814,7 +9928,7 @@
       </p:sp>
       <p:sp>
         <p:nvSpPr>
-          <p:cNvPr id="14" name="Shape 11"/>
+          <p:cNvPr id="27" name="Shape 11"/>
           <p:cNvSpPr/>
           <p:nvPr/>
         </p:nvSpPr>
@@ -10633,7 +10747,7 @@
       </p:sp>
       <p:sp>
         <p:nvSpPr>
-          <p:cNvPr id="14" name="Shape 11"/>
+          <p:cNvPr id="26" name="Shape 11"/>
           <p:cNvSpPr/>
           <p:nvPr/>
         </p:nvSpPr>
@@ -10662,7 +10776,7 @@
       </p:sp>
       <p:sp>
         <p:nvSpPr>
-          <p:cNvPr id="14" name="Shape 11"/>
+          <p:cNvPr id="27" name="Shape 11"/>
           <p:cNvSpPr/>
           <p:nvPr/>
         </p:nvSpPr>
@@ -11481,7 +11595,7 @@
       </p:sp>
       <p:sp>
         <p:nvSpPr>
-          <p:cNvPr id="14" name="Shape 11"/>
+          <p:cNvPr id="26" name="Shape 11"/>
           <p:cNvSpPr/>
           <p:nvPr/>
         </p:nvSpPr>
@@ -11510,7 +11624,7 @@
       </p:sp>
       <p:sp>
         <p:nvSpPr>
-          <p:cNvPr id="14" name="Shape 11"/>
+          <p:cNvPr id="27" name="Shape 11"/>
           <p:cNvSpPr/>
           <p:nvPr/>
         </p:nvSpPr>
@@ -12329,7 +12443,7 @@
       </p:sp>
       <p:sp>
         <p:nvSpPr>
-          <p:cNvPr id="14" name="Shape 11"/>
+          <p:cNvPr id="26" name="Shape 11"/>
           <p:cNvSpPr/>
           <p:nvPr/>
         </p:nvSpPr>
@@ -12358,7 +12472,7 @@
       </p:sp>
       <p:sp>
         <p:nvSpPr>
-          <p:cNvPr id="14" name="Shape 11"/>
+          <p:cNvPr id="27" name="Shape 11"/>
           <p:cNvSpPr/>
           <p:nvPr/>
         </p:nvSpPr>
@@ -13177,7 +13291,7 @@
       </p:sp>
       <p:sp>
         <p:nvSpPr>
-          <p:cNvPr id="14" name="Shape 11"/>
+          <p:cNvPr id="29" name="Shape 11"/>
           <p:cNvSpPr/>
           <p:nvPr/>
         </p:nvSpPr>
@@ -13206,7 +13320,7 @@
       </p:sp>
       <p:sp>
         <p:nvSpPr>
-          <p:cNvPr id="14" name="Shape 11"/>
+          <p:cNvPr id="30" name="Shape 11"/>
           <p:cNvSpPr/>
           <p:nvPr/>
         </p:nvSpPr>

</xml_diff>